<commit_message>
Fix empty placeholder prompts in SS3 Part C slides
Several slides shared a layout that declared chart and image
placeholders even on slides that never filled them, so PowerPoint
showed stray "Click to add text" prompts on top of the real content.
Split into a text-only layout and an exhibit layout (title only,
image/chart positioned directly instead of as named placeholders),
so nothing is ever left unfilled.
</commit_message>
<xml_diff>
--- a/SS3_PartC_Presentation.pptx
+++ b/SS3_PartC_Presentation.pptx
@@ -121,21 +121,21 @@
   <p:extLst>
     <p:ext uri="{521415D9-36F7-43E2-AB2F-B90AF26B5E84}">
       <p14:sectionLst xmlns:p14="http://schemas.microsoft.com/office/powerpoint/2010/main">
-        <p14:section name="SS1" id="{8a32cdce-823d-9b23-f6fa-c822ae2c075c}">
+        <p14:section name="SS1" id="{6761d155-2d1b-60df-91de-0686fc529d7b}">
           <p14:sldIdLst>
             <p14:sldId id="257"/>
             <p14:sldId id="258"/>
             <p14:sldId id="259"/>
           </p14:sldIdLst>
         </p14:section>
-        <p14:section name="SS2" id="{58718380-89e9-d56f-3922-a0fffb99e42f}">
+        <p14:section name="SS2" id="{b729b604-a54e-1209-981d-3f9e16177a06}">
           <p14:sldIdLst>
             <p14:sldId id="260"/>
             <p14:sldId id="261"/>
             <p14:sldId id="262"/>
           </p14:sldIdLst>
         </p14:section>
-        <p14:section name="SS3" id="{c4448285-cc64-8577-fe47-243997087100}">
+        <p14:section name="SS3" id="{8334ad6c-c484-19a8-d059-fcba364322fd}">
           <p14:sldIdLst>
             <p14:sldId id="263"/>
             <p14:sldId id="264"/>
@@ -146,7 +146,7 @@
             <p14:sldId id="269"/>
           </p14:sldIdLst>
         </p14:section>
-        <p14:section name="Default-1" id="{38a6db32-4e5e-4d53-df05-889326bf1cd3}">
+        <p14:section name="Default-1" id="{6b560f18-626b-c318-0602-f99f36f27fbc}">
           <p14:sldIdLst>
             <p14:sldId id="270"/>
           </p14:sldIdLst>
@@ -2358,7 +2358,7 @@
 
 <file path=ppt/slideLayouts/slideLayout4.xml><?xml version="1.0" encoding="utf-8"?>
 <p:sldLayout xmlns:a="http://schemas.openxmlformats.org/drawingml/2006/main" xmlns:r="http://schemas.openxmlformats.org/officeDocument/2006/relationships" xmlns:p="http://schemas.openxmlformats.org/presentationml/2006/main" preserve="1">
-  <p:cSld name="CONTENT_LIGHT">
+  <p:cSld name="CONTENT_TEXT">
     <p:bg>
       <p:bgPr>
         <a:solidFill>
@@ -2464,18 +2464,50 @@
           </a:p>
         </p:txBody>
       </p:sp>
-      <p:sp>
-        <p:nvSpPr>
-          <p:cNvPr id="4" name="Text 0"/>
+    </p:spTree>
+  </p:cSld>
+  <p:clrMapOvr>
+    <a:masterClrMapping/>
+  </p:clrMapOvr>
+</p:sldLayout>
+</file>
+
+<file path=ppt/slideLayouts/slideLayout5.xml><?xml version="1.0" encoding="utf-8"?>
+<p:sldLayout xmlns:a="http://schemas.openxmlformats.org/drawingml/2006/main" xmlns:r="http://schemas.openxmlformats.org/officeDocument/2006/relationships" xmlns:p="http://schemas.openxmlformats.org/presentationml/2006/main" preserve="1">
+  <p:cSld name="CONTENT_EXHIBIT">
+    <p:bg>
+      <p:bgPr>
+        <a:solidFill>
+          <a:srgbClr val="FFFFFF"/>
+        </a:solidFill>
+      </p:bgPr>
+    </p:bg>
+    <p:spTree>
+      <p:nvGrpSpPr>
+        <p:cNvPr id="1" name=""/>
+        <p:cNvGrpSpPr/>
+        <p:nvPr/>
+      </p:nvGrpSpPr>
+      <p:grpSpPr>
+        <a:xfrm>
+          <a:off x="0" y="0"/>
+          <a:ext cx="0" cy="0"/>
+          <a:chOff x="0" y="0"/>
+          <a:chExt cx="0" cy="0"/>
+        </a:xfrm>
+      </p:grpSpPr>
+      <p:sp>
+        <p:nvSpPr>
+          <p:cNvPr id="2" name="Text 0"/>
           <p:cNvSpPr/>
           <p:nvPr>
-            <p:ph idx="102" type="body" hasCustomPrompt="1"/>
-          </p:nvPr>
-        </p:nvSpPr>
-        <p:spPr>
-          <a:xfrm>
-            <a:off x="548640" y="1417320"/>
-            <a:ext cx="11064240" cy="4937760"/>
+            <p:ph idx="100" type="title" hasCustomPrompt="1"/>
+          </p:nvPr>
+        </p:nvSpPr>
+        <p:spPr>
+          <a:xfrm>
+            <a:off x="548640" y="411480"/>
+            <a:ext cx="11064240" cy="822960"/>
           </a:xfrm>
           <a:prstGeom prst="rect">
             <a:avLst/>
@@ -2486,51 +2518,23 @@
         <p:txBody>
           <a:bodyPr wrap="square" rtlCol="0"/>
           <a:lstStyle>
-            <a:lvl1pPr indent="0" marL="0">
+            <a:lvl1pPr algn="l" indent="0" marL="0">
               <a:buNone/>
-              <a:defRPr lang="en-US" dirty="0"/>
+              <a:defRPr lang="en-US" sz="3000" b="1" dirty="0">
+                <a:solidFill>
+                  <a:schemeClr val="tx2"/>
+                </a:solidFill>
+                <a:latin typeface="Cambria" pitchFamily="34" charset="0"/>
+                <a:ea typeface="Cambria" pitchFamily="34" charset="-122"/>
+                <a:cs typeface="Cambria" pitchFamily="34" charset="-120"/>
+              </a:defRPr>
             </a:lvl1pPr>
           </a:lstStyle>
           <a:p>
-            <a:pPr indent="0" marL="0">
+            <a:pPr algn="l" indent="0" marL="0">
               <a:buNone/>
             </a:pPr>
-            <a:endParaRPr lang="en-US" dirty="0"/>
-          </a:p>
-        </p:txBody>
-      </p:sp>
-      <p:sp>
-        <p:nvSpPr>
-          <p:cNvPr id="5" name="Text 0"/>
-          <p:cNvSpPr/>
-          <p:nvPr>
-            <p:ph idx="103" type="body" hasCustomPrompt="1"/>
-          </p:nvPr>
-        </p:nvSpPr>
-        <p:spPr>
-          <a:xfrm>
-            <a:off x="548640" y="1417320"/>
-            <a:ext cx="11064240" cy="4937760"/>
-          </a:xfrm>
-          <a:prstGeom prst="rect">
-            <a:avLst/>
-          </a:prstGeom>
-          <a:noFill/>
-          <a:ln/>
-        </p:spPr>
-        <p:txBody>
-          <a:bodyPr wrap="square" rtlCol="0"/>
-          <a:lstStyle>
-            <a:lvl1pPr indent="0" marL="0">
-              <a:buNone/>
-              <a:defRPr lang="en-US" dirty="0"/>
-            </a:lvl1pPr>
-          </a:lstStyle>
-          <a:p>
-            <a:pPr indent="0" marL="0">
-              <a:buNone/>
-            </a:pPr>
-            <a:endParaRPr lang="en-US" dirty="0"/>
+            <a:endParaRPr lang="en-US" sz="3000" dirty="0"/>
           </a:p>
         </p:txBody>
       </p:sp>
@@ -2567,6 +2571,7 @@
     <p:sldLayoutId id="2147483650" r:id="rId2"/>
     <p:sldLayoutId id="2147483651" r:id="rId3"/>
     <p:sldLayoutId id="2147483652" r:id="rId4"/>
+    <p:sldLayoutId id="2147483653" r:id="rId5"/>
   </p:sldLayoutIdLst>
   <p:hf sldNum="0" hdr="0" ftr="0" dt="0"/>
   <p:txStyles>
@@ -3125,66 +3130,6 @@
           </a:p>
         </p:txBody>
       </p:sp>
-      <p:sp>
-        <p:nvSpPr>
-          <p:cNvPr id="4" name="Text 0"/>
-          <p:cNvSpPr/>
-          <p:nvPr>
-            <p:ph idx="102" type="body" hasCustomPrompt="1"/>
-          </p:nvPr>
-        </p:nvSpPr>
-        <p:spPr>
-          <a:xfrm>
-            <a:off x="548640" y="1417320"/>
-            <a:ext cx="11064240" cy="4937760"/>
-          </a:xfrm>
-          <a:prstGeom prst="rect">
-            <a:avLst/>
-          </a:prstGeom>
-          <a:noFill/>
-          <a:ln/>
-        </p:spPr>
-        <p:txBody>
-          <a:bodyPr wrap="square" rtlCol="0"/>
-          <a:lstStyle/>
-          <a:p>
-            <a:pPr indent="0" marL="0">
-              <a:buNone/>
-            </a:pPr>
-            <a:endParaRPr lang="en-US" dirty="0"/>
-          </a:p>
-        </p:txBody>
-      </p:sp>
-      <p:sp>
-        <p:nvSpPr>
-          <p:cNvPr id="5" name="Text 0"/>
-          <p:cNvSpPr/>
-          <p:nvPr>
-            <p:ph idx="103" type="body" hasCustomPrompt="1"/>
-          </p:nvPr>
-        </p:nvSpPr>
-        <p:spPr>
-          <a:xfrm>
-            <a:off x="548640" y="1417320"/>
-            <a:ext cx="11064240" cy="4937760"/>
-          </a:xfrm>
-          <a:prstGeom prst="rect">
-            <a:avLst/>
-          </a:prstGeom>
-          <a:noFill/>
-          <a:ln/>
-        </p:spPr>
-        <p:txBody>
-          <a:bodyPr wrap="square" rtlCol="0"/>
-          <a:lstStyle/>
-          <a:p>
-            <a:pPr indent="0" marL="0">
-              <a:buNone/>
-            </a:pPr>
-            <a:endParaRPr lang="en-US" dirty="0"/>
-          </a:p>
-        </p:txBody>
-      </p:sp>
     </p:spTree>
   </p:cSld>
   <p:clrMapOvr>
@@ -3251,15 +3196,52 @@
           </a:p>
         </p:txBody>
       </p:sp>
+      <p:sp>
+        <p:nvSpPr>
+          <p:cNvPr id="3" name="Text 1"/>
+          <p:cNvSpPr txBox="1"/>
+          <p:nvPr/>
+        </p:nvSpPr>
+        <p:spPr>
+          <a:xfrm>
+            <a:off x="548640" y="1417320"/>
+            <a:ext cx="11064240" cy="457200"/>
+          </a:xfrm>
+          <a:prstGeom prst="rect">
+            <a:avLst/>
+          </a:prstGeom>
+          <a:noFill/>
+          <a:ln/>
+        </p:spPr>
+        <p:txBody>
+          <a:bodyPr wrap="square" rtlCol="0" anchor="t"/>
+          <a:lstStyle/>
+          <a:p>
+            <a:pPr indent="0" marL="0">
+              <a:buNone/>
+            </a:pPr>
+            <a:r>
+              <a:rPr lang="en-US" sz="1500" dirty="0">
+                <a:solidFill>
+                  <a:srgbClr val="1A1033"/>
+                </a:solidFill>
+                <a:latin typeface="Calibri" pitchFamily="34" charset="0"/>
+                <a:ea typeface="Calibri" pitchFamily="34" charset="-122"/>
+                <a:cs typeface="Calibri" pitchFamily="34" charset="-120"/>
+              </a:rPr>
+              <a:t>Test set: accuracy 0.858, recall 0.906, ROC-AUC 0.950. The single biggest predictor is days since a household's last viewing activity, exactly the kind of signal a retention team can act on and explain.</a:t>
+            </a:r>
+            <a:endParaRPr lang="en-US" sz="1500" dirty="0"/>
+          </a:p>
+        </p:txBody>
+      </p:sp>
       <p:pic>
         <p:nvPicPr>
-          <p:cNvPr id="3" name="Image 0" descr="../../../../../Desktop/CAP182_SS1/experimental_results/ss3_part_b_results.png">    </p:cNvPr>
+          <p:cNvPr id="4" name="Image 0" descr="../../../../../Desktop/CAP182_SS1/experimental_results/ss3_part_b_results.png">    </p:cNvPr>
           <p:cNvPicPr>
             <a:picLocks noChangeAspect="1"/>
           </p:cNvPicPr>
-          <p:nvPr>
-            <p:ph idx="103" type="body" hasCustomPrompt="1"/>
-          </p:nvPr>
+          <p:nvPr/>
         </p:nvPicPr>
         <p:blipFill>
           <a:blip r:embed="rId1"/>
@@ -3268,7 +3250,7 @@
         </p:blipFill>
         <p:spPr>
           <a:xfrm>
-            <a:off x="548640" y="1417320"/>
+            <a:off x="548640" y="1828800"/>
             <a:ext cx="11064240" cy="3566160"/>
           </a:xfrm>
           <a:prstGeom prst="rect">
@@ -3276,77 +3258,6 @@
           </a:prstGeom>
         </p:spPr>
       </p:pic>
-      <p:sp>
-        <p:nvSpPr>
-          <p:cNvPr id="4" name="Text 0"/>
-          <p:cNvSpPr/>
-          <p:nvPr>
-            <p:ph idx="101" type="body" hasCustomPrompt="1"/>
-          </p:nvPr>
-        </p:nvSpPr>
-        <p:spPr>
-          <a:xfrm>
-            <a:off x="548640" y="1417320"/>
-            <a:ext cx="11064240" cy="4937760"/>
-          </a:xfrm>
-          <a:prstGeom prst="rect">
-            <a:avLst/>
-          </a:prstGeom>
-          <a:noFill/>
-          <a:ln/>
-        </p:spPr>
-        <p:txBody>
-          <a:bodyPr wrap="square" rtlCol="0"/>
-          <a:lstStyle/>
-          <a:p>
-            <a:pPr algn="l" indent="0" marL="0">
-              <a:buNone/>
-            </a:pPr>
-            <a:r>
-              <a:rPr lang="en-US" sz="1600" dirty="0">
-                <a:solidFill>
-                  <a:schemeClr val="tx1"/>
-                </a:solidFill>
-                <a:latin typeface="Calibri" pitchFamily="34" charset="0"/>
-                <a:ea typeface="Calibri" pitchFamily="34" charset="-122"/>
-                <a:cs typeface="Calibri" pitchFamily="34" charset="-120"/>
-              </a:rPr>
-              <a:t>Test set: accuracy 0.858, recall 0.906, ROC-AUC 0.950. The single biggest predictor is days since a household's last viewing activity, exactly the kind of signal a retention team can act on and explain.</a:t>
-            </a:r>
-            <a:endParaRPr lang="en-US" sz="1600" dirty="0"/>
-          </a:p>
-        </p:txBody>
-      </p:sp>
-      <p:sp>
-        <p:nvSpPr>
-          <p:cNvPr id="5" name="Text 0"/>
-          <p:cNvSpPr/>
-          <p:nvPr>
-            <p:ph idx="102" type="body" hasCustomPrompt="1"/>
-          </p:nvPr>
-        </p:nvSpPr>
-        <p:spPr>
-          <a:xfrm>
-            <a:off x="548640" y="1417320"/>
-            <a:ext cx="11064240" cy="4937760"/>
-          </a:xfrm>
-          <a:prstGeom prst="rect">
-            <a:avLst/>
-          </a:prstGeom>
-          <a:noFill/>
-          <a:ln/>
-        </p:spPr>
-        <p:txBody>
-          <a:bodyPr wrap="square" rtlCol="0"/>
-          <a:lstStyle/>
-          <a:p>
-            <a:pPr indent="0" marL="0">
-              <a:buNone/>
-            </a:pPr>
-            <a:endParaRPr lang="en-US" dirty="0"/>
-          </a:p>
-        </p:txBody>
-      </p:sp>
     </p:spTree>
   </p:cSld>
   <p:clrMapOvr>
@@ -3417,13 +3328,11 @@
         <p:nvGraphicFramePr>
           <p:cNvPr id="3" name="Chart 0" descr=""/>
           <p:cNvGraphicFramePr/>
-          <p:nvPr>
-            <p:ph idx="102" type="body" hasCustomPrompt="1"/>
-          </p:nvPr>
+          <p:nvPr/>
         </p:nvGraphicFramePr>
         <p:xfrm>
-          <a:off x="548640" y="1417320"/>
-          <a:ext cx="11064240" cy="4937760"/>
+          <a:off x="1645920" y="1554480"/>
+          <a:ext cx="8869680" cy="4206240"/>
         </p:xfrm>
         <a:graphic xmlns:a="http://schemas.openxmlformats.org/drawingml/2006/main">
           <a:graphicData uri="http://schemas.openxmlformats.org/drawingml/2006/chart">
@@ -3431,66 +3340,6 @@
           </a:graphicData>
         </a:graphic>
       </p:graphicFrame>
-      <p:sp>
-        <p:nvSpPr>
-          <p:cNvPr id="4" name="Text 0"/>
-          <p:cNvSpPr/>
-          <p:nvPr>
-            <p:ph idx="101" type="body" hasCustomPrompt="1"/>
-          </p:nvPr>
-        </p:nvSpPr>
-        <p:spPr>
-          <a:xfrm>
-            <a:off x="548640" y="1417320"/>
-            <a:ext cx="11064240" cy="4937760"/>
-          </a:xfrm>
-          <a:prstGeom prst="rect">
-            <a:avLst/>
-          </a:prstGeom>
-          <a:noFill/>
-          <a:ln/>
-        </p:spPr>
-        <p:txBody>
-          <a:bodyPr wrap="square" rtlCol="0"/>
-          <a:lstStyle/>
-          <a:p>
-            <a:pPr algn="l" indent="0" marL="0">
-              <a:buNone/>
-            </a:pPr>
-            <a:endParaRPr lang="en-US" sz="1600" dirty="0"/>
-          </a:p>
-        </p:txBody>
-      </p:sp>
-      <p:sp>
-        <p:nvSpPr>
-          <p:cNvPr id="5" name="Text 0"/>
-          <p:cNvSpPr/>
-          <p:nvPr>
-            <p:ph idx="103" type="body" hasCustomPrompt="1"/>
-          </p:nvPr>
-        </p:nvSpPr>
-        <p:spPr>
-          <a:xfrm>
-            <a:off x="548640" y="1417320"/>
-            <a:ext cx="11064240" cy="4937760"/>
-          </a:xfrm>
-          <a:prstGeom prst="rect">
-            <a:avLst/>
-          </a:prstGeom>
-          <a:noFill/>
-          <a:ln/>
-        </p:spPr>
-        <p:txBody>
-          <a:bodyPr wrap="square" rtlCol="0"/>
-          <a:lstStyle/>
-          <a:p>
-            <a:pPr indent="0" marL="0">
-              <a:buNone/>
-            </a:pPr>
-            <a:endParaRPr lang="en-US" dirty="0"/>
-          </a:p>
-        </p:txBody>
-      </p:sp>
     </p:spTree>
   </p:cSld>
   <p:clrMapOvr>
@@ -3665,66 +3514,6 @@
           </a:p>
         </p:txBody>
       </p:sp>
-      <p:sp>
-        <p:nvSpPr>
-          <p:cNvPr id="4" name="Text 0"/>
-          <p:cNvSpPr/>
-          <p:nvPr>
-            <p:ph idx="102" type="body" hasCustomPrompt="1"/>
-          </p:nvPr>
-        </p:nvSpPr>
-        <p:spPr>
-          <a:xfrm>
-            <a:off x="548640" y="1417320"/>
-            <a:ext cx="11064240" cy="4937760"/>
-          </a:xfrm>
-          <a:prstGeom prst="rect">
-            <a:avLst/>
-          </a:prstGeom>
-          <a:noFill/>
-          <a:ln/>
-        </p:spPr>
-        <p:txBody>
-          <a:bodyPr wrap="square" rtlCol="0"/>
-          <a:lstStyle/>
-          <a:p>
-            <a:pPr indent="0" marL="0">
-              <a:buNone/>
-            </a:pPr>
-            <a:endParaRPr lang="en-US" dirty="0"/>
-          </a:p>
-        </p:txBody>
-      </p:sp>
-      <p:sp>
-        <p:nvSpPr>
-          <p:cNvPr id="5" name="Text 0"/>
-          <p:cNvSpPr/>
-          <p:nvPr>
-            <p:ph idx="103" type="body" hasCustomPrompt="1"/>
-          </p:nvPr>
-        </p:nvSpPr>
-        <p:spPr>
-          <a:xfrm>
-            <a:off x="548640" y="1417320"/>
-            <a:ext cx="11064240" cy="4937760"/>
-          </a:xfrm>
-          <a:prstGeom prst="rect">
-            <a:avLst/>
-          </a:prstGeom>
-          <a:noFill/>
-          <a:ln/>
-        </p:spPr>
-        <p:txBody>
-          <a:bodyPr wrap="square" rtlCol="0"/>
-          <a:lstStyle/>
-          <a:p>
-            <a:pPr indent="0" marL="0">
-              <a:buNone/>
-            </a:pPr>
-            <a:endParaRPr lang="en-US" dirty="0"/>
-          </a:p>
-        </p:txBody>
-      </p:sp>
     </p:spTree>
   </p:cSld>
   <p:clrMapOvr>
@@ -3878,66 +3667,6 @@
           </a:p>
         </p:txBody>
       </p:sp>
-      <p:sp>
-        <p:nvSpPr>
-          <p:cNvPr id="4" name="Text 0"/>
-          <p:cNvSpPr/>
-          <p:nvPr>
-            <p:ph idx="102" type="body" hasCustomPrompt="1"/>
-          </p:nvPr>
-        </p:nvSpPr>
-        <p:spPr>
-          <a:xfrm>
-            <a:off x="548640" y="1417320"/>
-            <a:ext cx="11064240" cy="4937760"/>
-          </a:xfrm>
-          <a:prstGeom prst="rect">
-            <a:avLst/>
-          </a:prstGeom>
-          <a:noFill/>
-          <a:ln/>
-        </p:spPr>
-        <p:txBody>
-          <a:bodyPr wrap="square" rtlCol="0"/>
-          <a:lstStyle/>
-          <a:p>
-            <a:pPr indent="0" marL="0">
-              <a:buNone/>
-            </a:pPr>
-            <a:endParaRPr lang="en-US" dirty="0"/>
-          </a:p>
-        </p:txBody>
-      </p:sp>
-      <p:sp>
-        <p:nvSpPr>
-          <p:cNvPr id="5" name="Text 0"/>
-          <p:cNvSpPr/>
-          <p:nvPr>
-            <p:ph idx="103" type="body" hasCustomPrompt="1"/>
-          </p:nvPr>
-        </p:nvSpPr>
-        <p:spPr>
-          <a:xfrm>
-            <a:off x="548640" y="1417320"/>
-            <a:ext cx="11064240" cy="4937760"/>
-          </a:xfrm>
-          <a:prstGeom prst="rect">
-            <a:avLst/>
-          </a:prstGeom>
-          <a:noFill/>
-          <a:ln/>
-        </p:spPr>
-        <p:txBody>
-          <a:bodyPr wrap="square" rtlCol="0"/>
-          <a:lstStyle/>
-          <a:p>
-            <a:pPr indent="0" marL="0">
-              <a:buNone/>
-            </a:pPr>
-            <a:endParaRPr lang="en-US" dirty="0"/>
-          </a:p>
-        </p:txBody>
-      </p:sp>
     </p:spTree>
   </p:cSld>
   <p:clrMapOvr>
@@ -4579,66 +4308,6 @@
           </a:p>
         </p:txBody>
       </p:sp>
-      <p:sp>
-        <p:nvSpPr>
-          <p:cNvPr id="13" name="Text 0"/>
-          <p:cNvSpPr/>
-          <p:nvPr>
-            <p:ph idx="102" type="body" hasCustomPrompt="1"/>
-          </p:nvPr>
-        </p:nvSpPr>
-        <p:spPr>
-          <a:xfrm>
-            <a:off x="548640" y="1417320"/>
-            <a:ext cx="11064240" cy="4937760"/>
-          </a:xfrm>
-          <a:prstGeom prst="rect">
-            <a:avLst/>
-          </a:prstGeom>
-          <a:noFill/>
-          <a:ln/>
-        </p:spPr>
-        <p:txBody>
-          <a:bodyPr wrap="square" rtlCol="0"/>
-          <a:lstStyle/>
-          <a:p>
-            <a:pPr indent="0" marL="0">
-              <a:buNone/>
-            </a:pPr>
-            <a:endParaRPr lang="en-US" dirty="0"/>
-          </a:p>
-        </p:txBody>
-      </p:sp>
-      <p:sp>
-        <p:nvSpPr>
-          <p:cNvPr id="14" name="Text 0"/>
-          <p:cNvSpPr/>
-          <p:nvPr>
-            <p:ph idx="103" type="body" hasCustomPrompt="1"/>
-          </p:nvPr>
-        </p:nvSpPr>
-        <p:spPr>
-          <a:xfrm>
-            <a:off x="548640" y="1417320"/>
-            <a:ext cx="11064240" cy="4937760"/>
-          </a:xfrm>
-          <a:prstGeom prst="rect">
-            <a:avLst/>
-          </a:prstGeom>
-          <a:noFill/>
-          <a:ln/>
-        </p:spPr>
-        <p:txBody>
-          <a:bodyPr wrap="square" rtlCol="0"/>
-          <a:lstStyle/>
-          <a:p>
-            <a:pPr indent="0" marL="0">
-              <a:buNone/>
-            </a:pPr>
-            <a:endParaRPr lang="en-US" dirty="0"/>
-          </a:p>
-        </p:txBody>
-      </p:sp>
     </p:spTree>
   </p:cSld>
   <p:clrMapOvr>
@@ -4813,66 +4482,6 @@
           </a:p>
         </p:txBody>
       </p:sp>
-      <p:sp>
-        <p:nvSpPr>
-          <p:cNvPr id="4" name="Text 0"/>
-          <p:cNvSpPr/>
-          <p:nvPr>
-            <p:ph idx="102" type="body" hasCustomPrompt="1"/>
-          </p:nvPr>
-        </p:nvSpPr>
-        <p:spPr>
-          <a:xfrm>
-            <a:off x="548640" y="1417320"/>
-            <a:ext cx="11064240" cy="4937760"/>
-          </a:xfrm>
-          <a:prstGeom prst="rect">
-            <a:avLst/>
-          </a:prstGeom>
-          <a:noFill/>
-          <a:ln/>
-        </p:spPr>
-        <p:txBody>
-          <a:bodyPr wrap="square" rtlCol="0"/>
-          <a:lstStyle/>
-          <a:p>
-            <a:pPr indent="0" marL="0">
-              <a:buNone/>
-            </a:pPr>
-            <a:endParaRPr lang="en-US" dirty="0"/>
-          </a:p>
-        </p:txBody>
-      </p:sp>
-      <p:sp>
-        <p:nvSpPr>
-          <p:cNvPr id="5" name="Text 0"/>
-          <p:cNvSpPr/>
-          <p:nvPr>
-            <p:ph idx="103" type="body" hasCustomPrompt="1"/>
-          </p:nvPr>
-        </p:nvSpPr>
-        <p:spPr>
-          <a:xfrm>
-            <a:off x="548640" y="1417320"/>
-            <a:ext cx="11064240" cy="4937760"/>
-          </a:xfrm>
-          <a:prstGeom prst="rect">
-            <a:avLst/>
-          </a:prstGeom>
-          <a:noFill/>
-          <a:ln/>
-        </p:spPr>
-        <p:txBody>
-          <a:bodyPr wrap="square" rtlCol="0"/>
-          <a:lstStyle/>
-          <a:p>
-            <a:pPr indent="0" marL="0">
-              <a:buNone/>
-            </a:pPr>
-            <a:endParaRPr lang="en-US" dirty="0"/>
-          </a:p>
-        </p:txBody>
-      </p:sp>
     </p:spTree>
   </p:cSld>
   <p:clrMapOvr>
@@ -5133,66 +4742,6 @@
           </a:p>
         </p:txBody>
       </p:sp>
-      <p:sp>
-        <p:nvSpPr>
-          <p:cNvPr id="4" name="Text 0"/>
-          <p:cNvSpPr/>
-          <p:nvPr>
-            <p:ph idx="102" type="body" hasCustomPrompt="1"/>
-          </p:nvPr>
-        </p:nvSpPr>
-        <p:spPr>
-          <a:xfrm>
-            <a:off x="548640" y="1417320"/>
-            <a:ext cx="11064240" cy="4937760"/>
-          </a:xfrm>
-          <a:prstGeom prst="rect">
-            <a:avLst/>
-          </a:prstGeom>
-          <a:noFill/>
-          <a:ln/>
-        </p:spPr>
-        <p:txBody>
-          <a:bodyPr wrap="square" rtlCol="0"/>
-          <a:lstStyle/>
-          <a:p>
-            <a:pPr indent="0" marL="0">
-              <a:buNone/>
-            </a:pPr>
-            <a:endParaRPr lang="en-US" dirty="0"/>
-          </a:p>
-        </p:txBody>
-      </p:sp>
-      <p:sp>
-        <p:nvSpPr>
-          <p:cNvPr id="5" name="Text 0"/>
-          <p:cNvSpPr/>
-          <p:nvPr>
-            <p:ph idx="103" type="body" hasCustomPrompt="1"/>
-          </p:nvPr>
-        </p:nvSpPr>
-        <p:spPr>
-          <a:xfrm>
-            <a:off x="548640" y="1417320"/>
-            <a:ext cx="11064240" cy="4937760"/>
-          </a:xfrm>
-          <a:prstGeom prst="rect">
-            <a:avLst/>
-          </a:prstGeom>
-          <a:noFill/>
-          <a:ln/>
-        </p:spPr>
-        <p:txBody>
-          <a:bodyPr wrap="square" rtlCol="0"/>
-          <a:lstStyle/>
-          <a:p>
-            <a:pPr indent="0" marL="0">
-              <a:buNone/>
-            </a:pPr>
-            <a:endParaRPr lang="en-US" dirty="0"/>
-          </a:p>
-        </p:txBody>
-      </p:sp>
     </p:spTree>
   </p:cSld>
   <p:clrMapOvr>
@@ -5265,9 +4814,7 @@
           <p:cNvPicPr>
             <a:picLocks noChangeAspect="1"/>
           </p:cNvPicPr>
-          <p:nvPr>
-            <p:ph idx="103" type="body" hasCustomPrompt="1"/>
-          </p:nvPr>
+          <p:nvPr/>
         </p:nvPicPr>
         <p:blipFill>
           <a:blip r:embed="rId1"/>
@@ -5276,7 +4823,7 @@
         </p:blipFill>
         <p:spPr>
           <a:xfrm>
-            <a:off x="548640" y="1417320"/>
+            <a:off x="1463040" y="1508760"/>
             <a:ext cx="6035040" cy="4526280"/>
           </a:xfrm>
           <a:prstGeom prst="rect">
@@ -5403,66 +4950,6 @@
               <a:t>XGBoost is the method carried forward into SS3.</a:t>
             </a:r>
             <a:endParaRPr lang="en-US" sz="1600" dirty="0"/>
-          </a:p>
-        </p:txBody>
-      </p:sp>
-      <p:sp>
-        <p:nvSpPr>
-          <p:cNvPr id="5" name="Text 0"/>
-          <p:cNvSpPr/>
-          <p:nvPr>
-            <p:ph idx="101" type="body" hasCustomPrompt="1"/>
-          </p:nvPr>
-        </p:nvSpPr>
-        <p:spPr>
-          <a:xfrm>
-            <a:off x="548640" y="1417320"/>
-            <a:ext cx="11064240" cy="4937760"/>
-          </a:xfrm>
-          <a:prstGeom prst="rect">
-            <a:avLst/>
-          </a:prstGeom>
-          <a:noFill/>
-          <a:ln/>
-        </p:spPr>
-        <p:txBody>
-          <a:bodyPr wrap="square" rtlCol="0"/>
-          <a:lstStyle/>
-          <a:p>
-            <a:pPr algn="l" indent="0" marL="0">
-              <a:buNone/>
-            </a:pPr>
-            <a:endParaRPr lang="en-US" sz="1600" dirty="0"/>
-          </a:p>
-        </p:txBody>
-      </p:sp>
-      <p:sp>
-        <p:nvSpPr>
-          <p:cNvPr id="6" name="Text 0"/>
-          <p:cNvSpPr/>
-          <p:nvPr>
-            <p:ph idx="102" type="body" hasCustomPrompt="1"/>
-          </p:nvPr>
-        </p:nvSpPr>
-        <p:spPr>
-          <a:xfrm>
-            <a:off x="548640" y="1417320"/>
-            <a:ext cx="11064240" cy="4937760"/>
-          </a:xfrm>
-          <a:prstGeom prst="rect">
-            <a:avLst/>
-          </a:prstGeom>
-          <a:noFill/>
-          <a:ln/>
-        </p:spPr>
-        <p:txBody>
-          <a:bodyPr wrap="square" rtlCol="0"/>
-          <a:lstStyle/>
-          <a:p>
-            <a:pPr indent="0" marL="0">
-              <a:buNone/>
-            </a:pPr>
-            <a:endParaRPr lang="en-US" dirty="0"/>
           </a:p>
         </p:txBody>
       </p:sp>
@@ -6077,66 +5564,6 @@
               <a:t>Every number above was found by profiling the data directly, not assumed from the client's warning that it would be messy, then fixed with a documented reason for each step.</a:t>
             </a:r>
             <a:endParaRPr lang="en-US" sz="1600" dirty="0"/>
-          </a:p>
-        </p:txBody>
-      </p:sp>
-      <p:sp>
-        <p:nvSpPr>
-          <p:cNvPr id="16" name="Text 0"/>
-          <p:cNvSpPr/>
-          <p:nvPr>
-            <p:ph idx="102" type="body" hasCustomPrompt="1"/>
-          </p:nvPr>
-        </p:nvSpPr>
-        <p:spPr>
-          <a:xfrm>
-            <a:off x="548640" y="1417320"/>
-            <a:ext cx="11064240" cy="4937760"/>
-          </a:xfrm>
-          <a:prstGeom prst="rect">
-            <a:avLst/>
-          </a:prstGeom>
-          <a:noFill/>
-          <a:ln/>
-        </p:spPr>
-        <p:txBody>
-          <a:bodyPr wrap="square" rtlCol="0"/>
-          <a:lstStyle/>
-          <a:p>
-            <a:pPr indent="0" marL="0">
-              <a:buNone/>
-            </a:pPr>
-            <a:endParaRPr lang="en-US" dirty="0"/>
-          </a:p>
-        </p:txBody>
-      </p:sp>
-      <p:sp>
-        <p:nvSpPr>
-          <p:cNvPr id="17" name="Text 0"/>
-          <p:cNvSpPr/>
-          <p:nvPr>
-            <p:ph idx="103" type="body" hasCustomPrompt="1"/>
-          </p:nvPr>
-        </p:nvSpPr>
-        <p:spPr>
-          <a:xfrm>
-            <a:off x="548640" y="1417320"/>
-            <a:ext cx="11064240" cy="4937760"/>
-          </a:xfrm>
-          <a:prstGeom prst="rect">
-            <a:avLst/>
-          </a:prstGeom>
-          <a:noFill/>
-          <a:ln/>
-        </p:spPr>
-        <p:txBody>
-          <a:bodyPr wrap="square" rtlCol="0"/>
-          <a:lstStyle/>
-          <a:p>
-            <a:pPr indent="0" marL="0">
-              <a:buNone/>
-            </a:pPr>
-            <a:endParaRPr lang="en-US" dirty="0"/>
           </a:p>
         </p:txBody>
       </p:sp>

</xml_diff>